<commit_message>
Se actualiza la clase 5
</commit_message>
<xml_diff>
--- a/clases/5/teoria/clase-05.pptx
+++ b/clases/5/teoria/clase-05.pptx
@@ -6684,7 +6684,7 @@
           <a:p>
             <a:fld id="{30943A3E-55B9-4706-BA6E-9364B5247742}" type="datetimeFigureOut">
               <a:rPr lang="es-CO" smtClean="0"/>
-              <a:t>21/08/2026</a:t>
+              <a:t>23/08/2026</a:t>
             </a:fld>
             <a:endParaRPr lang="es-CO"/>
           </a:p>
@@ -7422,7 +7422,7 @@
           <a:p>
             <a:fld id="{78FAE389-1891-4C1C-AE7B-96446A92669F}" type="datetime1">
               <a:rPr lang="es-CO" smtClean="0"/>
-              <a:t>21/08/2026</a:t>
+              <a:t>23/08/2026</a:t>
             </a:fld>
             <a:endParaRPr lang="es-CO" dirty="0"/>
           </a:p>
@@ -7594,7 +7594,7 @@
           <a:p>
             <a:fld id="{169921E5-6957-4C84-BD80-156D13F58C59}" type="datetime1">
               <a:rPr lang="es-CO" smtClean="0"/>
-              <a:t>21/08/2026</a:t>
+              <a:t>23/08/2026</a:t>
             </a:fld>
             <a:endParaRPr lang="es-CO"/>
           </a:p>
@@ -7774,7 +7774,7 @@
           <a:p>
             <a:fld id="{A7BB61D7-E979-4A0B-B106-A9203ABD6AA5}" type="datetime1">
               <a:rPr lang="es-CO" smtClean="0"/>
-              <a:t>21/08/2026</a:t>
+              <a:t>23/08/2026</a:t>
             </a:fld>
             <a:endParaRPr lang="es-CO"/>
           </a:p>
@@ -7944,7 +7944,7 @@
           <a:p>
             <a:fld id="{BC197211-2E02-4E34-9D1C-742DBBA2E713}" type="datetime1">
               <a:rPr lang="es-CO" smtClean="0"/>
-              <a:t>21/08/2026</a:t>
+              <a:t>23/08/2026</a:t>
             </a:fld>
             <a:endParaRPr lang="es-CO"/>
           </a:p>
@@ -8114,7 +8114,7 @@
           <a:p>
             <a:fld id="{BC197211-2E02-4E34-9D1C-742DBBA2E713}" type="datetime1">
               <a:rPr lang="es-CO" smtClean="0"/>
-              <a:t>21/08/2026</a:t>
+              <a:t>23/08/2026</a:t>
             </a:fld>
             <a:endParaRPr lang="es-CO"/>
           </a:p>
@@ -8358,7 +8358,7 @@
           <a:p>
             <a:fld id="{F84A16AA-8F92-4F8D-9FF5-AE4F5F025475}" type="datetime1">
               <a:rPr lang="es-CO" smtClean="0"/>
-              <a:t>21/08/2026</a:t>
+              <a:t>23/08/2026</a:t>
             </a:fld>
             <a:endParaRPr lang="es-CO"/>
           </a:p>
@@ -8590,7 +8590,7 @@
           <a:p>
             <a:fld id="{58A2889A-C4A3-4C6C-A514-E9566A95FF0B}" type="datetime1">
               <a:rPr lang="es-CO" smtClean="0"/>
-              <a:t>21/08/2026</a:t>
+              <a:t>23/08/2026</a:t>
             </a:fld>
             <a:endParaRPr lang="es-CO"/>
           </a:p>
@@ -8957,7 +8957,7 @@
           <a:p>
             <a:fld id="{CFC549B8-F78E-4015-8DD3-99AC842EEF5C}" type="datetime1">
               <a:rPr lang="es-CO" smtClean="0"/>
-              <a:t>21/08/2026</a:t>
+              <a:t>23/08/2026</a:t>
             </a:fld>
             <a:endParaRPr lang="es-CO"/>
           </a:p>
@@ -9075,7 +9075,7 @@
           <a:p>
             <a:fld id="{78FAE389-1891-4C1C-AE7B-96446A92669F}" type="datetime1">
               <a:rPr lang="es-CO" smtClean="0"/>
-              <a:t>21/08/2026</a:t>
+              <a:t>23/08/2026</a:t>
             </a:fld>
             <a:endParaRPr lang="es-CO" dirty="0"/>
           </a:p>
@@ -9172,7 +9172,7 @@
           <a:p>
             <a:fld id="{C2375FDE-4F9B-4FF4-9D4F-6D3ED15F62CE}" type="datetime1">
               <a:rPr lang="es-CO" smtClean="0"/>
-              <a:t>21/08/2026</a:t>
+              <a:t>23/08/2026</a:t>
             </a:fld>
             <a:endParaRPr lang="es-CO"/>
           </a:p>
@@ -9449,7 +9449,7 @@
           <a:p>
             <a:fld id="{7AF392FA-6414-43D4-857F-1D16849F2AFB}" type="datetime1">
               <a:rPr lang="es-CO" smtClean="0"/>
-              <a:t>21/08/2026</a:t>
+              <a:t>23/08/2026</a:t>
             </a:fld>
             <a:endParaRPr lang="es-CO"/>
           </a:p>
@@ -9706,7 +9706,7 @@
           <a:p>
             <a:fld id="{E2F1ADB1-43E6-4CC5-8BA6-A3F5A7E6EF55}" type="datetime1">
               <a:rPr lang="es-CO" smtClean="0"/>
-              <a:t>21/08/2026</a:t>
+              <a:t>23/08/2026</a:t>
             </a:fld>
             <a:endParaRPr lang="es-CO"/>
           </a:p>
@@ -9919,7 +9919,7 @@
           <a:p>
             <a:fld id="{78FAE389-1891-4C1C-AE7B-96446A92669F}" type="datetime1">
               <a:rPr lang="es-CO" smtClean="0"/>
-              <a:t>21/08/2026</a:t>
+              <a:t>23/08/2026</a:t>
             </a:fld>
             <a:endParaRPr lang="es-CO" dirty="0"/>
           </a:p>
@@ -10385,7 +10385,7 @@
           <a:p>
             <a:r>
               <a:rPr lang="es-CO" sz="3200" b="1" dirty="0"/>
-              <a:t>Conceptos básicos de Python</a:t>
+              <a:t>Condicionales</a:t>
             </a:r>
           </a:p>
           <a:p>
@@ -22901,30 +22901,6 @@
       </p:sp>
       <p:sp>
         <p:nvSpPr>
-          <p:cNvPr id="4" name="Slide Number Placeholder 3"/>
-          <p:cNvSpPr>
-            <a:spLocks noGrp="1"/>
-          </p:cNvSpPr>
-          <p:nvPr>
-            <p:ph type="sldNum" sz="quarter" idx="12"/>
-          </p:nvPr>
-        </p:nvSpPr>
-        <p:spPr/>
-        <p:txBody>
-          <a:bodyPr/>
-          <a:lstStyle/>
-          <a:p>
-            <a:fld id="{45F1CE28-A3C7-48DC-84A2-8FB08D6123C5}" type="slidenum">
-              <a:rPr lang="en-US" smtClean="0"/>
-              <a:pPr/>
-              <a:t>19</a:t>
-            </a:fld>
-            <a:endParaRPr lang="en-US" dirty="0"/>
-          </a:p>
-        </p:txBody>
-      </p:sp>
-      <p:sp>
-        <p:nvSpPr>
           <p:cNvPr id="22" name="TextBox 75">
             <a:extLst>
               <a:ext uri="{FF2B5EF4-FFF2-40B4-BE49-F238E27FC236}">
@@ -24358,30 +24334,6 @@
           </a:p>
         </p:txBody>
       </p:sp>
-      <p:sp>
-        <p:nvSpPr>
-          <p:cNvPr id="4" name="Slide Number Placeholder 3"/>
-          <p:cNvSpPr>
-            <a:spLocks noGrp="1"/>
-          </p:cNvSpPr>
-          <p:nvPr>
-            <p:ph type="sldNum" sz="quarter" idx="12"/>
-          </p:nvPr>
-        </p:nvSpPr>
-        <p:spPr/>
-        <p:txBody>
-          <a:bodyPr/>
-          <a:lstStyle/>
-          <a:p>
-            <a:fld id="{45F1CE28-A3C7-48DC-84A2-8FB08D6123C5}" type="slidenum">
-              <a:rPr lang="en-US" smtClean="0"/>
-              <a:pPr/>
-              <a:t>2</a:t>
-            </a:fld>
-            <a:endParaRPr lang="en-US" dirty="0"/>
-          </a:p>
-        </p:txBody>
-      </p:sp>
       <p:graphicFrame>
         <p:nvGraphicFramePr>
           <p:cNvPr id="6" name="13 Diagrama">
@@ -24395,13 +24347,13 @@
           <p:nvPr>
             <p:extLst>
               <p:ext uri="{D42A27DB-BD31-4B8C-83A1-F6EECF244321}">
-                <p14:modId xmlns:p14="http://schemas.microsoft.com/office/powerpoint/2010/main" val="2388316973"/>
+                <p14:modId xmlns:p14="http://schemas.microsoft.com/office/powerpoint/2010/main" val="3245553215"/>
               </p:ext>
             </p:extLst>
           </p:nvPr>
         </p:nvGraphicFramePr>
         <p:xfrm>
-          <a:off x="3059832" y="4293096"/>
+          <a:off x="3059832" y="4221088"/>
           <a:ext cx="5616624" cy="2363788"/>
         </p:xfrm>
         <a:graphic>
@@ -24866,30 +24818,6 @@
               <a:rPr lang="es-ES" sz="2000" dirty="0"/>
               <a:t>).</a:t>
             </a:r>
-          </a:p>
-        </p:txBody>
-      </p:sp>
-      <p:sp>
-        <p:nvSpPr>
-          <p:cNvPr id="4" name="3 Marcador de número de diapositiva"/>
-          <p:cNvSpPr>
-            <a:spLocks noGrp="1"/>
-          </p:cNvSpPr>
-          <p:nvPr>
-            <p:ph type="sldNum" sz="quarter" idx="12"/>
-          </p:nvPr>
-        </p:nvSpPr>
-        <p:spPr/>
-        <p:txBody>
-          <a:bodyPr/>
-          <a:lstStyle/>
-          <a:p>
-            <a:fld id="{45F1CE28-A3C7-48DC-84A2-8FB08D6123C5}" type="slidenum">
-              <a:rPr lang="en-US" smtClean="0"/>
-              <a:pPr/>
-              <a:t>20</a:t>
-            </a:fld>
-            <a:endParaRPr lang="en-US" dirty="0"/>
           </a:p>
         </p:txBody>
       </p:sp>
@@ -26236,30 +26164,6 @@
       </p:sp>
       <p:sp>
         <p:nvSpPr>
-          <p:cNvPr id="4" name="3 Marcador de número de diapositiva"/>
-          <p:cNvSpPr>
-            <a:spLocks noGrp="1"/>
-          </p:cNvSpPr>
-          <p:nvPr>
-            <p:ph type="sldNum" sz="quarter" idx="12"/>
-          </p:nvPr>
-        </p:nvSpPr>
-        <p:spPr/>
-        <p:txBody>
-          <a:bodyPr/>
-          <a:lstStyle/>
-          <a:p>
-            <a:fld id="{45F1CE28-A3C7-48DC-84A2-8FB08D6123C5}" type="slidenum">
-              <a:rPr lang="en-US" smtClean="0"/>
-              <a:pPr/>
-              <a:t>22</a:t>
-            </a:fld>
-            <a:endParaRPr lang="en-US" dirty="0"/>
-          </a:p>
-        </p:txBody>
-      </p:sp>
-      <p:sp>
-        <p:nvSpPr>
           <p:cNvPr id="3" name="2 Rectángulo"/>
           <p:cNvSpPr/>
           <p:nvPr/>
@@ -26390,30 +26294,6 @@
               <a:rPr lang="es-CO" dirty="0"/>
               <a:t>Condicionales</a:t>
             </a:r>
-          </a:p>
-        </p:txBody>
-      </p:sp>
-      <p:sp>
-        <p:nvSpPr>
-          <p:cNvPr id="4" name="3 Marcador de número de diapositiva"/>
-          <p:cNvSpPr>
-            <a:spLocks noGrp="1"/>
-          </p:cNvSpPr>
-          <p:nvPr>
-            <p:ph type="sldNum" sz="quarter" idx="12"/>
-          </p:nvPr>
-        </p:nvSpPr>
-        <p:spPr/>
-        <p:txBody>
-          <a:bodyPr/>
-          <a:lstStyle/>
-          <a:p>
-            <a:fld id="{45F1CE28-A3C7-48DC-84A2-8FB08D6123C5}" type="slidenum">
-              <a:rPr lang="en-US" smtClean="0"/>
-              <a:pPr/>
-              <a:t>23</a:t>
-            </a:fld>
-            <a:endParaRPr lang="en-US" dirty="0"/>
           </a:p>
         </p:txBody>
       </p:sp>
@@ -26889,30 +26769,6 @@
       </p:sp>
       <p:sp>
         <p:nvSpPr>
-          <p:cNvPr id="4" name="3 Marcador de número de diapositiva"/>
-          <p:cNvSpPr>
-            <a:spLocks noGrp="1"/>
-          </p:cNvSpPr>
-          <p:nvPr>
-            <p:ph type="sldNum" sz="quarter" idx="12"/>
-          </p:nvPr>
-        </p:nvSpPr>
-        <p:spPr/>
-        <p:txBody>
-          <a:bodyPr/>
-          <a:lstStyle/>
-          <a:p>
-            <a:fld id="{45F1CE28-A3C7-48DC-84A2-8FB08D6123C5}" type="slidenum">
-              <a:rPr lang="en-US" smtClean="0"/>
-              <a:pPr/>
-              <a:t>24</a:t>
-            </a:fld>
-            <a:endParaRPr lang="en-US" dirty="0"/>
-          </a:p>
-        </p:txBody>
-      </p:sp>
-      <p:sp>
-        <p:nvSpPr>
           <p:cNvPr id="9" name="8 Rectángulo"/>
           <p:cNvSpPr/>
           <p:nvPr/>
@@ -27384,30 +27240,6 @@
       </p:sp>
       <p:sp>
         <p:nvSpPr>
-          <p:cNvPr id="4" name="3 Marcador de número de diapositiva"/>
-          <p:cNvSpPr>
-            <a:spLocks noGrp="1"/>
-          </p:cNvSpPr>
-          <p:nvPr>
-            <p:ph type="sldNum" sz="quarter" idx="12"/>
-          </p:nvPr>
-        </p:nvSpPr>
-        <p:spPr/>
-        <p:txBody>
-          <a:bodyPr/>
-          <a:lstStyle/>
-          <a:p>
-            <a:fld id="{45F1CE28-A3C7-48DC-84A2-8FB08D6123C5}" type="slidenum">
-              <a:rPr lang="en-US" smtClean="0"/>
-              <a:pPr/>
-              <a:t>25</a:t>
-            </a:fld>
-            <a:endParaRPr lang="en-US" dirty="0"/>
-          </a:p>
-        </p:txBody>
-      </p:sp>
-      <p:sp>
-        <p:nvSpPr>
           <p:cNvPr id="3" name="2 Rectángulo"/>
           <p:cNvSpPr/>
           <p:nvPr/>
@@ -27867,30 +27699,6 @@
               <a:rPr lang="es-CO" dirty="0"/>
               <a:t>Condicionales</a:t>
             </a:r>
-          </a:p>
-        </p:txBody>
-      </p:sp>
-      <p:sp>
-        <p:nvSpPr>
-          <p:cNvPr id="4" name="3 Marcador de número de diapositiva"/>
-          <p:cNvSpPr>
-            <a:spLocks noGrp="1"/>
-          </p:cNvSpPr>
-          <p:nvPr>
-            <p:ph type="sldNum" sz="quarter" idx="12"/>
-          </p:nvPr>
-        </p:nvSpPr>
-        <p:spPr/>
-        <p:txBody>
-          <a:bodyPr/>
-          <a:lstStyle/>
-          <a:p>
-            <a:fld id="{45F1CE28-A3C7-48DC-84A2-8FB08D6123C5}" type="slidenum">
-              <a:rPr lang="en-US" smtClean="0"/>
-              <a:pPr/>
-              <a:t>26</a:t>
-            </a:fld>
-            <a:endParaRPr lang="en-US" dirty="0"/>
           </a:p>
         </p:txBody>
       </p:sp>
@@ -28804,30 +28612,6 @@
       </p:sp>
       <p:sp>
         <p:nvSpPr>
-          <p:cNvPr id="4" name="3 Marcador de número de diapositiva"/>
-          <p:cNvSpPr>
-            <a:spLocks noGrp="1"/>
-          </p:cNvSpPr>
-          <p:nvPr>
-            <p:ph type="sldNum" sz="quarter" idx="12"/>
-          </p:nvPr>
-        </p:nvSpPr>
-        <p:spPr/>
-        <p:txBody>
-          <a:bodyPr/>
-          <a:lstStyle/>
-          <a:p>
-            <a:fld id="{45F1CE28-A3C7-48DC-84A2-8FB08D6123C5}" type="slidenum">
-              <a:rPr lang="en-US" smtClean="0"/>
-              <a:pPr/>
-              <a:t>28</a:t>
-            </a:fld>
-            <a:endParaRPr lang="en-US" dirty="0"/>
-          </a:p>
-        </p:txBody>
-      </p:sp>
-      <p:sp>
-        <p:nvSpPr>
           <p:cNvPr id="13" name="12 Rectángulo"/>
           <p:cNvSpPr/>
           <p:nvPr/>
@@ -29303,30 +29087,6 @@
               <a:rPr lang="es-CO" sz="4000" dirty="0"/>
               <a:t>Alternativa simple</a:t>
             </a:r>
-          </a:p>
-        </p:txBody>
-      </p:sp>
-      <p:sp>
-        <p:nvSpPr>
-          <p:cNvPr id="4" name="3 Marcador de número de diapositiva"/>
-          <p:cNvSpPr>
-            <a:spLocks noGrp="1"/>
-          </p:cNvSpPr>
-          <p:nvPr>
-            <p:ph type="sldNum" sz="quarter" idx="12"/>
-          </p:nvPr>
-        </p:nvSpPr>
-        <p:spPr/>
-        <p:txBody>
-          <a:bodyPr/>
-          <a:lstStyle/>
-          <a:p>
-            <a:fld id="{45F1CE28-A3C7-48DC-84A2-8FB08D6123C5}" type="slidenum">
-              <a:rPr lang="en-US" smtClean="0"/>
-              <a:pPr/>
-              <a:t>29</a:t>
-            </a:fld>
-            <a:endParaRPr lang="en-US" dirty="0"/>
           </a:p>
         </p:txBody>
       </p:sp>
@@ -32159,30 +31919,6 @@
       </p:sp>
       <p:sp>
         <p:nvSpPr>
-          <p:cNvPr id="4" name="3 Marcador de número de diapositiva"/>
-          <p:cNvSpPr>
-            <a:spLocks noGrp="1"/>
-          </p:cNvSpPr>
-          <p:nvPr>
-            <p:ph type="sldNum" sz="quarter" idx="12"/>
-          </p:nvPr>
-        </p:nvSpPr>
-        <p:spPr/>
-        <p:txBody>
-          <a:bodyPr/>
-          <a:lstStyle/>
-          <a:p>
-            <a:fld id="{45F1CE28-A3C7-48DC-84A2-8FB08D6123C5}" type="slidenum">
-              <a:rPr lang="en-US" smtClean="0"/>
-              <a:pPr/>
-              <a:t>32</a:t>
-            </a:fld>
-            <a:endParaRPr lang="en-US" dirty="0"/>
-          </a:p>
-        </p:txBody>
-      </p:sp>
-      <p:sp>
-        <p:nvSpPr>
           <p:cNvPr id="13" name="12 Rectángulo"/>
           <p:cNvSpPr/>
           <p:nvPr/>
@@ -32318,30 +32054,6 @@
       </p:sp>
       <p:sp>
         <p:nvSpPr>
-          <p:cNvPr id="4" name="3 Marcador de número de diapositiva"/>
-          <p:cNvSpPr>
-            <a:spLocks noGrp="1"/>
-          </p:cNvSpPr>
-          <p:nvPr>
-            <p:ph type="sldNum" sz="quarter" idx="12"/>
-          </p:nvPr>
-        </p:nvSpPr>
-        <p:spPr/>
-        <p:txBody>
-          <a:bodyPr/>
-          <a:lstStyle/>
-          <a:p>
-            <a:fld id="{45F1CE28-A3C7-48DC-84A2-8FB08D6123C5}" type="slidenum">
-              <a:rPr lang="en-US" smtClean="0"/>
-              <a:pPr/>
-              <a:t>33</a:t>
-            </a:fld>
-            <a:endParaRPr lang="en-US" dirty="0"/>
-          </a:p>
-        </p:txBody>
-      </p:sp>
-      <p:sp>
-        <p:nvSpPr>
           <p:cNvPr id="13" name="12 Rectángulo"/>
           <p:cNvSpPr/>
           <p:nvPr/>
@@ -32763,30 +32475,6 @@
               <a:rPr lang="es-CO" dirty="0"/>
               <a:t>Alternativa simple</a:t>
             </a:r>
-          </a:p>
-        </p:txBody>
-      </p:sp>
-      <p:sp>
-        <p:nvSpPr>
-          <p:cNvPr id="4" name="3 Marcador de número de diapositiva"/>
-          <p:cNvSpPr>
-            <a:spLocks noGrp="1"/>
-          </p:cNvSpPr>
-          <p:nvPr>
-            <p:ph type="sldNum" sz="quarter" idx="12"/>
-          </p:nvPr>
-        </p:nvSpPr>
-        <p:spPr/>
-        <p:txBody>
-          <a:bodyPr/>
-          <a:lstStyle/>
-          <a:p>
-            <a:fld id="{45F1CE28-A3C7-48DC-84A2-8FB08D6123C5}" type="slidenum">
-              <a:rPr lang="en-US" smtClean="0"/>
-              <a:pPr/>
-              <a:t>34</a:t>
-            </a:fld>
-            <a:endParaRPr lang="en-US" dirty="0"/>
           </a:p>
         </p:txBody>
       </p:sp>
@@ -33109,9 +32797,9 @@
         <p:grpSpPr>
           <a:xfrm>
             <a:off x="506904" y="1124744"/>
-            <a:ext cx="8202163" cy="2303543"/>
+            <a:ext cx="8202163" cy="2241988"/>
             <a:chOff x="506904" y="1052736"/>
-            <a:chExt cx="8202163" cy="2303543"/>
+            <a:chExt cx="8202163" cy="2241988"/>
           </a:xfrm>
         </p:grpSpPr>
         <p:sp>
@@ -33468,9 +33156,9 @@
           <p:grpSpPr>
             <a:xfrm>
               <a:off x="3450428" y="1750429"/>
-              <a:ext cx="2771285" cy="1605850"/>
+              <a:ext cx="2920365" cy="1544295"/>
               <a:chOff x="3450428" y="1750429"/>
-              <a:chExt cx="2771285" cy="1605850"/>
+              <a:chExt cx="2920365" cy="1544295"/>
             </a:xfrm>
           </p:grpSpPr>
           <p:grpSp>
@@ -33608,9 +33296,9 @@
             <p:grpSpPr>
               <a:xfrm>
                 <a:off x="3450428" y="2448164"/>
-                <a:ext cx="2771285" cy="908115"/>
+                <a:ext cx="2920365" cy="846560"/>
                 <a:chOff x="3450428" y="2448164"/>
-                <a:chExt cx="2771285" cy="908115"/>
+                <a:chExt cx="2920365" cy="846560"/>
               </a:xfrm>
             </p:grpSpPr>
             <p:sp>
@@ -33622,7 +33310,7 @@
               <p:spPr>
                 <a:xfrm>
                   <a:off x="3552393" y="2833059"/>
-                  <a:ext cx="2669320" cy="523220"/>
+                  <a:ext cx="2818400" cy="461665"/>
                 </a:xfrm>
                 <a:prstGeom prst="rect">
                   <a:avLst/>
@@ -33635,14 +33323,14 @@
                 <a:lstStyle/>
                 <a:p>
                   <a:r>
-                    <a:rPr lang="es-CO" sz="1400" dirty="0">
+                    <a:rPr lang="es-CO" sz="1200" dirty="0">
                       <a:latin typeface="Consolas" panose="020B0609020204030204" pitchFamily="49" charset="0"/>
                       <a:cs typeface="Consolas" panose="020B0609020204030204" pitchFamily="49" charset="0"/>
                     </a:rPr>
                     <a:t>subsidio </a:t>
                   </a:r>
                   <a:r>
-                    <a:rPr lang="es-CO" sz="1400" dirty="0">
+                    <a:rPr lang="es-CO" sz="1200" dirty="0">
                       <a:latin typeface="Consolas" panose="020B0609020204030204" pitchFamily="49" charset="0"/>
                       <a:cs typeface="Consolas" panose="020B0609020204030204" pitchFamily="49" charset="0"/>
                       <a:sym typeface="Wingdings" panose="05000000000000000000" pitchFamily="2" charset="2"/>
@@ -33652,14 +33340,14 @@
                 </a:p>
                 <a:p>
                   <a:r>
-                    <a:rPr lang="es-CO" sz="1400" dirty="0">
+                    <a:rPr lang="es-CO" sz="1200" dirty="0">
                       <a:latin typeface="Consolas" panose="020B0609020204030204" pitchFamily="49" charset="0"/>
                       <a:cs typeface="Consolas" panose="020B0609020204030204" pitchFamily="49" charset="0"/>
                     </a:rPr>
                     <a:t>sal_neto </a:t>
                   </a:r>
                   <a:r>
-                    <a:rPr lang="es-CO" sz="1400" dirty="0">
+                    <a:rPr lang="es-CO" sz="1200" dirty="0">
                       <a:latin typeface="Consolas" panose="020B0609020204030204" pitchFamily="49" charset="0"/>
                       <a:cs typeface="Consolas" panose="020B0609020204030204" pitchFamily="49" charset="0"/>
                       <a:sym typeface="Wingdings" panose="05000000000000000000" pitchFamily="2" charset="2"/>
@@ -33667,13 +33355,13 @@
                     <a:t>= </a:t>
                   </a:r>
                   <a:r>
-                    <a:rPr lang="es-CO" sz="1400" dirty="0">
+                    <a:rPr lang="es-CO" sz="1200" dirty="0">
                       <a:latin typeface="Consolas" panose="020B0609020204030204" pitchFamily="49" charset="0"/>
                       <a:cs typeface="Consolas" panose="020B0609020204030204" pitchFamily="49" charset="0"/>
                     </a:rPr>
-                    <a:t>sal_base + sub</a:t>
+                    <a:t>sal_base + subsidio</a:t>
                   </a:r>
-                  <a:endParaRPr lang="es-CO" sz="1400" dirty="0">
+                  <a:endParaRPr lang="es-CO" sz="1200" dirty="0">
                     <a:latin typeface="Consolas" panose="020B0609020204030204" pitchFamily="49" charset="0"/>
                     <a:cs typeface="Consolas" panose="020B0609020204030204" pitchFamily="49" charset="0"/>
                     <a:sym typeface="Wingdings" panose="05000000000000000000" pitchFamily="2" charset="2"/>
@@ -33837,7 +33525,7 @@
               <a:rPr lang="es-CO" sz="1200" dirty="0">
                 <a:latin typeface="Consolas" panose="020B0609020204030204" pitchFamily="49" charset="0"/>
               </a:rPr>
-              <a:t>SALARIO_MIN = 20000000</a:t>
+              <a:t>SALARIO_MIN = 2000000</a:t>
             </a:r>
           </a:p>
           <a:p>
@@ -34070,7 +33758,7 @@
               <a:rPr lang="es-MX" sz="1200" dirty="0">
                 <a:latin typeface="Consolas" panose="020B0609020204030204" pitchFamily="49" charset="0"/>
               </a:rPr>
-              <a:t>  Si (sal_base &lt; 2000000) Entonces    </a:t>
+              <a:t>  Si (sal_base &lt; SALARIO_MIN) Entonces    </a:t>
             </a:r>
           </a:p>
           <a:p>
@@ -34244,30 +33932,6 @@
               <a:rPr lang="es-CO" dirty="0"/>
               <a:t>Alternativa simple</a:t>
             </a:r>
-          </a:p>
-        </p:txBody>
-      </p:sp>
-      <p:sp>
-        <p:nvSpPr>
-          <p:cNvPr id="4" name="3 Marcador de número de diapositiva"/>
-          <p:cNvSpPr>
-            <a:spLocks noGrp="1"/>
-          </p:cNvSpPr>
-          <p:nvPr>
-            <p:ph type="sldNum" sz="quarter" idx="12"/>
-          </p:nvPr>
-        </p:nvSpPr>
-        <p:spPr/>
-        <p:txBody>
-          <a:bodyPr/>
-          <a:lstStyle/>
-          <a:p>
-            <a:fld id="{45F1CE28-A3C7-48DC-84A2-8FB08D6123C5}" type="slidenum">
-              <a:rPr lang="en-US" smtClean="0"/>
-              <a:pPr/>
-              <a:t>36</a:t>
-            </a:fld>
-            <a:endParaRPr lang="en-US" dirty="0"/>
           </a:p>
         </p:txBody>
       </p:sp>
@@ -35203,30 +34867,6 @@
       </p:sp>
       <p:sp>
         <p:nvSpPr>
-          <p:cNvPr id="4" name="3 Marcador de número de diapositiva"/>
-          <p:cNvSpPr>
-            <a:spLocks noGrp="1"/>
-          </p:cNvSpPr>
-          <p:nvPr>
-            <p:ph type="sldNum" sz="quarter" idx="12"/>
-          </p:nvPr>
-        </p:nvSpPr>
-        <p:spPr/>
-        <p:txBody>
-          <a:bodyPr/>
-          <a:lstStyle/>
-          <a:p>
-            <a:fld id="{45F1CE28-A3C7-48DC-84A2-8FB08D6123C5}" type="slidenum">
-              <a:rPr lang="en-US" smtClean="0"/>
-              <a:pPr/>
-              <a:t>37</a:t>
-            </a:fld>
-            <a:endParaRPr lang="en-US" dirty="0"/>
-          </a:p>
-        </p:txBody>
-      </p:sp>
-      <p:sp>
-        <p:nvSpPr>
           <p:cNvPr id="13" name="12 Rectángulo"/>
           <p:cNvSpPr/>
           <p:nvPr/>
@@ -35891,30 +35531,6 @@
               <a:rPr lang="es-CO" dirty="0"/>
               <a:t>Alternativa doble</a:t>
             </a:r>
-          </a:p>
-        </p:txBody>
-      </p:sp>
-      <p:sp>
-        <p:nvSpPr>
-          <p:cNvPr id="4" name="3 Marcador de número de diapositiva"/>
-          <p:cNvSpPr>
-            <a:spLocks noGrp="1"/>
-          </p:cNvSpPr>
-          <p:nvPr>
-            <p:ph type="sldNum" sz="quarter" idx="12"/>
-          </p:nvPr>
-        </p:nvSpPr>
-        <p:spPr/>
-        <p:txBody>
-          <a:bodyPr/>
-          <a:lstStyle/>
-          <a:p>
-            <a:fld id="{45F1CE28-A3C7-48DC-84A2-8FB08D6123C5}" type="slidenum">
-              <a:rPr lang="en-US" smtClean="0"/>
-              <a:pPr/>
-              <a:t>39</a:t>
-            </a:fld>
-            <a:endParaRPr lang="en-US" dirty="0"/>
           </a:p>
         </p:txBody>
       </p:sp>
@@ -36944,30 +36560,6 @@
       </p:sp>
       <p:sp>
         <p:nvSpPr>
-          <p:cNvPr id="4" name="3 Marcador de número de diapositiva"/>
-          <p:cNvSpPr>
-            <a:spLocks noGrp="1"/>
-          </p:cNvSpPr>
-          <p:nvPr>
-            <p:ph type="sldNum" sz="quarter" idx="12"/>
-          </p:nvPr>
-        </p:nvSpPr>
-        <p:spPr/>
-        <p:txBody>
-          <a:bodyPr/>
-          <a:lstStyle/>
-          <a:p>
-            <a:fld id="{45F1CE28-A3C7-48DC-84A2-8FB08D6123C5}" type="slidenum">
-              <a:rPr lang="en-US" smtClean="0"/>
-              <a:pPr/>
-              <a:t>40</a:t>
-            </a:fld>
-            <a:endParaRPr lang="en-US" dirty="0"/>
-          </a:p>
-        </p:txBody>
-      </p:sp>
-      <p:sp>
-        <p:nvSpPr>
           <p:cNvPr id="13" name="12 Rectángulo"/>
           <p:cNvSpPr/>
           <p:nvPr/>
@@ -39083,30 +38675,6 @@
           </a:p>
         </p:txBody>
       </p:sp>
-      <p:sp>
-        <p:nvSpPr>
-          <p:cNvPr id="4" name="Slide Number Placeholder 3"/>
-          <p:cNvSpPr>
-            <a:spLocks noGrp="1"/>
-          </p:cNvSpPr>
-          <p:nvPr>
-            <p:ph type="sldNum" sz="quarter" idx="12"/>
-          </p:nvPr>
-        </p:nvSpPr>
-        <p:spPr/>
-        <p:txBody>
-          <a:bodyPr/>
-          <a:lstStyle/>
-          <a:p>
-            <a:fld id="{45F1CE28-A3C7-48DC-84A2-8FB08D6123C5}" type="slidenum">
-              <a:rPr lang="en-US" smtClean="0"/>
-              <a:pPr/>
-              <a:t>45</a:t>
-            </a:fld>
-            <a:endParaRPr lang="en-US" dirty="0"/>
-          </a:p>
-        </p:txBody>
-      </p:sp>
     </p:spTree>
     <p:extLst>
       <p:ext uri="{BB962C8B-B14F-4D97-AF65-F5344CB8AC3E}">
@@ -39311,10 +38879,10 @@
         </p:nvGrpSpPr>
         <p:grpSpPr>
           <a:xfrm>
-            <a:off x="470918" y="3717032"/>
-            <a:ext cx="8369418" cy="2179240"/>
+            <a:off x="470918" y="3984017"/>
+            <a:ext cx="8202163" cy="1821247"/>
             <a:chOff x="470918" y="3717032"/>
-            <a:chExt cx="8369418" cy="2179240"/>
+            <a:chExt cx="8202163" cy="1821247"/>
           </a:xfrm>
         </p:grpSpPr>
         <p:grpSp>
@@ -39824,8 +39392,8 @@
           </p:blipFill>
           <p:spPr bwMode="auto">
             <a:xfrm>
-              <a:off x="7164288" y="4521771"/>
-              <a:ext cx="1676048" cy="1374501"/>
+              <a:off x="7487440" y="4636199"/>
+              <a:ext cx="1099984" cy="902080"/>
             </a:xfrm>
             <a:prstGeom prst="rect">
               <a:avLst/>
@@ -39842,43 +39410,6 @@
             </a:extLst>
           </p:spPr>
         </p:pic>
-        <p:sp>
-          <p:nvSpPr>
-            <p:cNvPr id="26" name="1 Rectángulo">
-              <a:extLst>
-                <a:ext uri="{FF2B5EF4-FFF2-40B4-BE49-F238E27FC236}">
-                  <a16:creationId xmlns:a16="http://schemas.microsoft.com/office/drawing/2014/main" id="{E2B87FE0-3E51-4A21-8CA3-74E832542A5C}"/>
-                </a:ext>
-              </a:extLst>
-            </p:cNvPr>
-            <p:cNvSpPr/>
-            <p:nvPr/>
-          </p:nvSpPr>
-          <p:spPr>
-            <a:xfrm>
-              <a:off x="7545362" y="4659762"/>
-              <a:ext cx="1018227" cy="230832"/>
-            </a:xfrm>
-            <a:prstGeom prst="rect">
-              <a:avLst/>
-            </a:prstGeom>
-          </p:spPr>
-          <p:txBody>
-            <a:bodyPr wrap="none">
-              <a:spAutoFit/>
-            </a:bodyPr>
-            <a:lstStyle/>
-            <a:p>
-              <a:r>
-                <a:rPr lang="es-CO" sz="900" dirty="0">
-                  <a:latin typeface="Consolas" panose="020B0609020204030204" pitchFamily="49" charset="0"/>
-                  <a:cs typeface="Consolas" panose="020B0609020204030204" pitchFamily="49" charset="0"/>
-                </a:rPr>
-                <a:t>Mayor de edad</a:t>
-              </a:r>
-            </a:p>
-          </p:txBody>
-        </p:sp>
       </p:grpSp>
     </p:spTree>
     <p:extLst>
@@ -40019,30 +39550,6 @@
       </p:sp>
       <p:sp>
         <p:nvSpPr>
-          <p:cNvPr id="4" name="3 Marcador de número de diapositiva"/>
-          <p:cNvSpPr>
-            <a:spLocks noGrp="1"/>
-          </p:cNvSpPr>
-          <p:nvPr>
-            <p:ph type="sldNum" sz="quarter" idx="12"/>
-          </p:nvPr>
-        </p:nvSpPr>
-        <p:spPr/>
-        <p:txBody>
-          <a:bodyPr/>
-          <a:lstStyle/>
-          <a:p>
-            <a:fld id="{45F1CE28-A3C7-48DC-84A2-8FB08D6123C5}" type="slidenum">
-              <a:rPr lang="en-US" smtClean="0"/>
-              <a:pPr/>
-              <a:t>47</a:t>
-            </a:fld>
-            <a:endParaRPr lang="en-US" dirty="0"/>
-          </a:p>
-        </p:txBody>
-      </p:sp>
-      <p:sp>
-        <p:nvSpPr>
           <p:cNvPr id="6" name="CuadroTexto 5">
             <a:extLst>
               <a:ext uri="{FF2B5EF4-FFF2-40B4-BE49-F238E27FC236}">
@@ -40094,7 +39601,19 @@
               <a:rPr lang="es-CO" sz="1400" dirty="0">
                 <a:latin typeface="Consolas" panose="020B0609020204030204" pitchFamily="49" charset="0"/>
               </a:rPr>
-              <a:t>if(edad &gt;= 18):</a:t>
+              <a:t>if(edad &gt;= </a:t>
+            </a:r>
+            <a:r>
+              <a:rPr lang="es-MX" sz="1400" dirty="0">
+                <a:latin typeface="Consolas" panose="020B0609020204030204" pitchFamily="49" charset="0"/>
+              </a:rPr>
+              <a:t>MAYORIA_EDAD</a:t>
+            </a:r>
+            <a:r>
+              <a:rPr lang="es-CO" sz="1400" dirty="0">
+                <a:latin typeface="Consolas" panose="020B0609020204030204" pitchFamily="49" charset="0"/>
+              </a:rPr>
+              <a:t>):</a:t>
             </a:r>
           </a:p>
           <a:p>
@@ -40259,7 +39778,7 @@
               <a:rPr lang="es-MX" sz="1400" dirty="0">
                 <a:latin typeface="Consolas" panose="020B0609020204030204" pitchFamily="49" charset="0"/>
               </a:rPr>
-              <a:t>  Si (edad &gt;= 10) Entonces    </a:t>
+              <a:t>  Si (edad &gt;= MAYORIA_EDAD) Entonces    </a:t>
             </a:r>
           </a:p>
           <a:p>
@@ -41118,7 +40637,7 @@
               <a:rPr lang="es-MX" sz="1400" dirty="0">
                 <a:latin typeface="Consolas" panose="020B0609020204030204" pitchFamily="49" charset="0"/>
               </a:rPr>
-              <a:t>  Si (edad &gt;= 10) Entonces    </a:t>
+              <a:t>  Si (edad &gt;= MAYORIA_EDAD) Entonces    </a:t>
             </a:r>
           </a:p>
           <a:p>
@@ -43225,30 +42744,6 @@
       </p:sp>
       <p:sp>
         <p:nvSpPr>
-          <p:cNvPr id="4" name="3 Marcador de número de diapositiva"/>
-          <p:cNvSpPr>
-            <a:spLocks noGrp="1"/>
-          </p:cNvSpPr>
-          <p:nvPr>
-            <p:ph type="sldNum" sz="quarter" idx="12"/>
-          </p:nvPr>
-        </p:nvSpPr>
-        <p:spPr/>
-        <p:txBody>
-          <a:bodyPr/>
-          <a:lstStyle/>
-          <a:p>
-            <a:fld id="{45F1CE28-A3C7-48DC-84A2-8FB08D6123C5}" type="slidenum">
-              <a:rPr lang="en-US" smtClean="0"/>
-              <a:pPr/>
-              <a:t>50</a:t>
-            </a:fld>
-            <a:endParaRPr lang="en-US" dirty="0"/>
-          </a:p>
-        </p:txBody>
-      </p:sp>
-      <p:sp>
-        <p:nvSpPr>
           <p:cNvPr id="10" name="CuadroTexto 9">
             <a:extLst>
               <a:ext uri="{FF2B5EF4-FFF2-40B4-BE49-F238E27FC236}">
@@ -43656,30 +43151,6 @@
               <a:t>Ejemplos de repaso</a:t>
             </a:r>
             <a:endParaRPr lang="es-CO" dirty="0"/>
-          </a:p>
-        </p:txBody>
-      </p:sp>
-      <p:sp>
-        <p:nvSpPr>
-          <p:cNvPr id="4" name="3 Marcador de número de diapositiva"/>
-          <p:cNvSpPr>
-            <a:spLocks noGrp="1"/>
-          </p:cNvSpPr>
-          <p:nvPr>
-            <p:ph type="sldNum" sz="quarter" idx="12"/>
-          </p:nvPr>
-        </p:nvSpPr>
-        <p:spPr/>
-        <p:txBody>
-          <a:bodyPr/>
-          <a:lstStyle/>
-          <a:p>
-            <a:fld id="{45F1CE28-A3C7-48DC-84A2-8FB08D6123C5}" type="slidenum">
-              <a:rPr lang="en-US" smtClean="0"/>
-              <a:pPr/>
-              <a:t>51</a:t>
-            </a:fld>
-            <a:endParaRPr lang="en-US" dirty="0"/>
           </a:p>
         </p:txBody>
       </p:sp>
@@ -44828,8 +44299,8 @@
           </a:p>
         </p:txBody>
       </p:sp>
-      <mc:AlternateContent xmlns:mc="http://schemas.openxmlformats.org/markup-compatibility/2006">
-        <mc:Choice xmlns:a14="http://schemas.microsoft.com/office/drawing/2010/main" Requires="a14">
+      <mc:AlternateContent xmlns:mc="http://schemas.openxmlformats.org/markup-compatibility/2006" xmlns:a14="http://schemas.microsoft.com/office/drawing/2010/main">
+        <mc:Choice Requires="a14">
           <p:sp>
             <p:nvSpPr>
               <p:cNvPr id="2" name="Content Placeholder 1"/>
@@ -44915,19 +44386,27 @@
                     </m:oMathParaPr>
                     <m:oMath xmlns:m="http://schemas.openxmlformats.org/officeDocument/2006/math">
                       <m:r>
-                        <a:rPr lang="es-MX" sz="1800" b="0" i="1" smtClean="0"/>
+                        <a:rPr lang="es-MX" sz="1800" b="0" i="1" smtClean="0">
+                          <a:latin typeface="Cambria Math" panose="02040503050406030204" pitchFamily="18" charset="0"/>
+                        </a:rPr>
                         <m:t>𝑓</m:t>
                       </m:r>
                       <m:r>
-                        <a:rPr lang="es-MX" sz="1800" b="0" i="1" smtClean="0"/>
+                        <a:rPr lang="es-MX" sz="1800" b="0" i="1" smtClean="0">
+                          <a:latin typeface="Cambria Math" panose="02040503050406030204" pitchFamily="18" charset="0"/>
+                        </a:rPr>
                         <m:t>(</m:t>
                       </m:r>
                       <m:r>
-                        <a:rPr lang="es-MX" sz="1800" b="0" i="1" smtClean="0"/>
+                        <a:rPr lang="es-MX" sz="1800" b="0" i="1" smtClean="0">
+                          <a:latin typeface="Cambria Math" panose="02040503050406030204" pitchFamily="18" charset="0"/>
+                        </a:rPr>
                         <m:t>𝑥</m:t>
                       </m:r>
                       <m:r>
-                        <a:rPr lang="es-MX" sz="1800" b="0" i="1" smtClean="0"/>
+                        <a:rPr lang="es-MX" sz="1800" b="0" i="1" smtClean="0">
+                          <a:latin typeface="Cambria Math" panose="02040503050406030204" pitchFamily="18" charset="0"/>
+                        </a:rPr>
                         <m:t>)=</m:t>
                       </m:r>
                       <m:d>
@@ -44935,14 +44414,18 @@
                           <m:begChr m:val="{"/>
                           <m:endChr m:val=""/>
                           <m:ctrlPr>
-                            <a:rPr lang="es-MX" sz="1800" b="0" i="1" smtClean="0"/>
+                            <a:rPr lang="es-MX" sz="1800" b="0" i="1" smtClean="0">
+                              <a:latin typeface="Cambria Math" panose="02040503050406030204" pitchFamily="18" charset="0"/>
+                            </a:rPr>
                           </m:ctrlPr>
                         </m:dPr>
                         <m:e>
                           <m:eqArr>
                             <m:eqArrPr>
                               <m:ctrlPr>
-                                <a:rPr lang="es-MX" sz="1800" b="0" i="1" smtClean="0"/>
+                                <a:rPr lang="es-MX" sz="1800" b="0" i="1" smtClean="0">
+                                  <a:latin typeface="Cambria Math" panose="02040503050406030204" pitchFamily="18" charset="0"/>
+                                </a:rPr>
                               </m:ctrlPr>
                             </m:eqArrPr>
                             <m:e>
@@ -44957,7 +44440,9 @@
                                     </m:mc>
                                   </m:mcs>
                                   <m:ctrlPr>
-                                    <a:rPr lang="es-MX" sz="1800" b="0" i="1" smtClean="0"/>
+                                    <a:rPr lang="es-MX" sz="1800" b="0" i="1" smtClean="0">
+                                      <a:latin typeface="Cambria Math" panose="02040503050406030204" pitchFamily="18" charset="0"/>
+                                    </a:rPr>
                                   </m:ctrlPr>
                                 </m:mPr>
                                 <m:mr>
@@ -44965,7 +44450,9 @@
                                     <m:sSup>
                                       <m:sSupPr>
                                         <m:ctrlPr>
-                                          <a:rPr lang="es-MX" sz="1800" b="0" i="1" smtClean="0"/>
+                                          <a:rPr lang="es-MX" sz="1800" b="0" i="1" smtClean="0">
+                                            <a:latin typeface="Cambria Math" panose="02040503050406030204" pitchFamily="18" charset="0"/>
+                                          </a:rPr>
                                         </m:ctrlPr>
                                       </m:sSupPr>
                                       <m:e>
@@ -44973,7 +44460,9 @@
                                           <m:rPr>
                                             <m:brk m:alnAt="7"/>
                                           </m:rPr>
-                                          <a:rPr lang="es-MX" sz="1800" b="0" i="1" smtClean="0"/>
+                                          <a:rPr lang="es-MX" sz="1800" b="0" i="1" smtClean="0">
+                                            <a:latin typeface="Cambria Math" panose="02040503050406030204" pitchFamily="18" charset="0"/>
+                                          </a:rPr>
                                           <m:t>𝑥</m:t>
                                         </m:r>
                                       </m:e>
@@ -44982,7 +44471,9 @@
                                           <m:rPr>
                                             <m:brk m:alnAt="7"/>
                                           </m:rPr>
-                                          <a:rPr lang="es-MX" sz="1800" b="0" i="1" smtClean="0"/>
+                                          <a:rPr lang="es-MX" sz="1800" b="0" i="1" smtClean="0">
+                                            <a:latin typeface="Cambria Math" panose="02040503050406030204" pitchFamily="18" charset="0"/>
+                                          </a:rPr>
                                           <m:t>2</m:t>
                                         </m:r>
                                       </m:sup>
@@ -44991,11 +44482,15 @@
                                       <m:rPr>
                                         <m:brk m:alnAt="7"/>
                                       </m:rPr>
-                                      <a:rPr lang="es-MX" sz="1800" b="0" i="1" smtClean="0"/>
+                                      <a:rPr lang="es-MX" sz="1800" b="0" i="1" smtClean="0">
+                                        <a:latin typeface="Cambria Math" panose="02040503050406030204" pitchFamily="18" charset="0"/>
+                                      </a:rPr>
                                       <m:t>−</m:t>
                                     </m:r>
                                     <m:r>
-                                      <a:rPr lang="es-MX" sz="1800" b="0" i="1" smtClean="0"/>
+                                      <a:rPr lang="es-MX" sz="1800" b="0" i="1" smtClean="0">
+                                        <a:latin typeface="Cambria Math" panose="02040503050406030204" pitchFamily="18" charset="0"/>
+                                      </a:rPr>
                                       <m:t>𝑥</m:t>
                                     </m:r>
                                   </m:e>
@@ -45004,19 +44499,27 @@
                                       <m:rPr>
                                         <m:sty m:val="p"/>
                                       </m:rPr>
-                                      <a:rPr lang="es-MX" sz="1800" b="0" i="0" smtClean="0"/>
+                                      <a:rPr lang="es-MX" sz="1800" b="0" i="0" smtClean="0">
+                                        <a:latin typeface="Cambria Math" panose="02040503050406030204" pitchFamily="18" charset="0"/>
+                                      </a:rPr>
                                       <m:t>para</m:t>
                                     </m:r>
                                     <m:r>
-                                      <a:rPr lang="es-MX" sz="1800" b="0" i="1" smtClean="0"/>
+                                      <a:rPr lang="es-MX" sz="1800" b="0" i="1" smtClean="0">
+                                        <a:latin typeface="Cambria Math" panose="02040503050406030204" pitchFamily="18" charset="0"/>
+                                      </a:rPr>
                                       <m:t> </m:t>
                                     </m:r>
                                     <m:r>
-                                      <a:rPr lang="es-MX" sz="1800" b="0" i="1" smtClean="0"/>
+                                      <a:rPr lang="es-MX" sz="1800" b="0" i="1" smtClean="0">
+                                        <a:latin typeface="Cambria Math" panose="02040503050406030204" pitchFamily="18" charset="0"/>
+                                      </a:rPr>
                                       <m:t>𝑥</m:t>
                                     </m:r>
                                     <m:r>
-                                      <a:rPr lang="es-MX" sz="1800" b="0" i="1" smtClean="0"/>
+                                      <a:rPr lang="es-MX" sz="1800" b="0" i="1" smtClean="0">
+                                        <a:latin typeface="Cambria Math" panose="02040503050406030204" pitchFamily="18" charset="0"/>
+                                      </a:rPr>
                                       <m:t>≤0</m:t>
                                     </m:r>
                                   </m:e>
@@ -45035,7 +44538,9 @@
                                     </m:mc>
                                   </m:mcs>
                                   <m:ctrlPr>
-                                    <a:rPr lang="es-MX" sz="1800" b="0" i="1" smtClean="0"/>
+                                    <a:rPr lang="es-MX" sz="1800" b="0" i="1" smtClean="0">
+                                      <a:latin typeface="Cambria Math" panose="02040503050406030204" pitchFamily="18" charset="0"/>
+                                    </a:rPr>
                                   </m:ctrlPr>
                                 </m:mPr>
                                 <m:mr>
@@ -45044,13 +44549,17 @@
                                       <m:rPr>
                                         <m:brk m:alnAt="7"/>
                                       </m:rPr>
-                                      <a:rPr lang="es-MX" sz="1800" b="0" i="1" smtClean="0"/>
+                                      <a:rPr lang="es-MX" sz="1800" b="0" i="1" smtClean="0">
+                                        <a:latin typeface="Cambria Math" panose="02040503050406030204" pitchFamily="18" charset="0"/>
+                                      </a:rPr>
                                       <m:t>−</m:t>
                                     </m:r>
                                     <m:sSup>
                                       <m:sSupPr>
                                         <m:ctrlPr>
-                                          <a:rPr lang="es-MX" sz="1800" b="0" i="1" smtClean="0"/>
+                                          <a:rPr lang="es-MX" sz="1800" b="0" i="1" smtClean="0">
+                                            <a:latin typeface="Cambria Math" panose="02040503050406030204" pitchFamily="18" charset="0"/>
+                                          </a:rPr>
                                         </m:ctrlPr>
                                       </m:sSupPr>
                                       <m:e>
@@ -45058,7 +44567,9 @@
                                           <m:rPr>
                                             <m:brk m:alnAt="7"/>
                                           </m:rPr>
-                                          <a:rPr lang="es-MX" sz="1800" b="0" i="1" smtClean="0"/>
+                                          <a:rPr lang="es-MX" sz="1800" b="0" i="1" smtClean="0">
+                                            <a:latin typeface="Cambria Math" panose="02040503050406030204" pitchFamily="18" charset="0"/>
+                                          </a:rPr>
                                           <m:t>𝑥</m:t>
                                         </m:r>
                                       </m:e>
@@ -45067,7 +44578,9 @@
                                           <m:rPr>
                                             <m:brk m:alnAt="7"/>
                                           </m:rPr>
-                                          <a:rPr lang="es-MX" sz="1800" b="0" i="1" smtClean="0"/>
+                                          <a:rPr lang="es-MX" sz="1800" b="0" i="1" smtClean="0">
+                                            <a:latin typeface="Cambria Math" panose="02040503050406030204" pitchFamily="18" charset="0"/>
+                                          </a:rPr>
                                           <m:t>2</m:t>
                                         </m:r>
                                       </m:sup>
@@ -45076,15 +44589,21 @@
                                       <m:rPr>
                                         <m:brk m:alnAt="7"/>
                                       </m:rPr>
-                                      <a:rPr lang="es-MX" sz="1800" b="0" i="1" smtClean="0"/>
+                                      <a:rPr lang="es-MX" sz="1800" b="0" i="1" smtClean="0">
+                                        <a:latin typeface="Cambria Math" panose="02040503050406030204" pitchFamily="18" charset="0"/>
+                                      </a:rPr>
                                       <m:t>+</m:t>
                                     </m:r>
                                     <m:r>
-                                      <a:rPr lang="es-MX" sz="1800" b="0" i="1" smtClean="0"/>
+                                      <a:rPr lang="es-MX" sz="1800" b="0" i="1" smtClean="0">
+                                        <a:latin typeface="Cambria Math" panose="02040503050406030204" pitchFamily="18" charset="0"/>
+                                      </a:rPr>
                                       <m:t>3</m:t>
                                     </m:r>
                                     <m:r>
-                                      <a:rPr lang="es-MX" sz="1800" b="0" i="1" smtClean="0"/>
+                                      <a:rPr lang="es-MX" sz="1800" b="0" i="1" smtClean="0">
+                                        <a:latin typeface="Cambria Math" panose="02040503050406030204" pitchFamily="18" charset="0"/>
+                                      </a:rPr>
                                       <m:t>𝑥</m:t>
                                     </m:r>
                                   </m:e>
@@ -45093,19 +44612,27 @@
                                       <m:rPr>
                                         <m:sty m:val="p"/>
                                       </m:rPr>
-                                      <a:rPr lang="es-MX" sz="1800" b="0" i="0" smtClean="0"/>
+                                      <a:rPr lang="es-MX" sz="1800" b="0" i="0" smtClean="0">
+                                        <a:latin typeface="Cambria Math" panose="02040503050406030204" pitchFamily="18" charset="0"/>
+                                      </a:rPr>
                                       <m:t>para</m:t>
                                     </m:r>
                                     <m:r>
-                                      <a:rPr lang="es-MX" sz="1800" b="0" i="1" smtClean="0"/>
+                                      <a:rPr lang="es-MX" sz="1800" b="0" i="1" smtClean="0">
+                                        <a:latin typeface="Cambria Math" panose="02040503050406030204" pitchFamily="18" charset="0"/>
+                                      </a:rPr>
                                       <m:t> </m:t>
                                     </m:r>
                                     <m:r>
-                                      <a:rPr lang="es-MX" sz="1800" b="0" i="1" smtClean="0"/>
+                                      <a:rPr lang="es-MX" sz="1800" b="0" i="1" smtClean="0">
+                                        <a:latin typeface="Cambria Math" panose="02040503050406030204" pitchFamily="18" charset="0"/>
+                                      </a:rPr>
                                       <m:t>𝑥</m:t>
                                     </m:r>
                                     <m:r>
-                                      <a:rPr lang="es-MX" sz="1800" b="0" i="1" smtClean="0"/>
+                                      <a:rPr lang="es-MX" sz="1800" b="0" i="1" smtClean="0">
+                                        <a:latin typeface="Cambria Math" panose="02040503050406030204" pitchFamily="18" charset="0"/>
+                                      </a:rPr>
                                       <m:t>&gt;0</m:t>
                                     </m:r>
                                   </m:e>
@@ -45126,7 +44653,15 @@
                 </a:pPr>
                 <a:r>
                   <a:rPr lang="es-CO" sz="1800" dirty="0"/>
-                  <a:t>Hacer un programa que solicite dos números diferentes de tal manera que si el primero es mayor que el primero, los deje igual; y si el segundo es mayor que el primero, los intercambie.</a:t>
+                  <a:t>Hacer un programa que solicite </a:t>
+                </a:r>
+                <a:r>
+                  <a:rPr lang="es-CO" sz="1800"/>
+                  <a:t>dos números </a:t>
+                </a:r>
+                <a:r>
+                  <a:rPr lang="es-CO" sz="1800" dirty="0"/>
+                  <a:t>de tal manera que si el primero es mayor que el primero, los deje igual; y si el segundo es mayor que el primero, los intercambie.</a:t>
                 </a:r>
               </a:p>
               <a:p>
@@ -45161,7 +44696,7 @@
             </p:txBody>
           </p:sp>
         </mc:Choice>
-        <mc:Fallback>
+        <mc:Fallback xmlns="">
           <p:sp>
             <p:nvSpPr>
               <p:cNvPr id="2" name="Content Placeholder 1"/>
@@ -45180,7 +44715,7 @@
               <a:blipFill>
                 <a:blip r:embed="rId2"/>
                 <a:stretch>
-                  <a:fillRect t="-1130" r="-139"/>
+                  <a:fillRect t="-1130"/>
                 </a:stretch>
               </a:blipFill>
             </p:spPr>
@@ -46497,7 +46032,13 @@
           <p:cNvGraphicFramePr>
             <a:graphicFrameLocks noGrp="1"/>
           </p:cNvGraphicFramePr>
-          <p:nvPr/>
+          <p:nvPr>
+            <p:extLst>
+              <p:ext uri="{D42A27DB-BD31-4B8C-83A1-F6EECF244321}">
+                <p14:modId xmlns:p14="http://schemas.microsoft.com/office/powerpoint/2010/main" val="3219546523"/>
+              </p:ext>
+            </p:extLst>
+          </p:nvPr>
         </p:nvGraphicFramePr>
         <p:xfrm>
           <a:off x="467544" y="4465841"/>
@@ -46923,7 +46464,7 @@
                       <a:pPr algn="ctr"/>
                       <a:r>
                         <a:rPr lang="es-CO" sz="1400" dirty="0"/>
-                        <a:t>21.237</a:t>
+                        <a:t>21.226</a:t>
                       </a:r>
                     </a:p>
                   </a:txBody>
@@ -47166,30 +46707,6 @@
           </a:p>
         </p:txBody>
       </p:sp>
-      <p:sp>
-        <p:nvSpPr>
-          <p:cNvPr id="4" name="3 Marcador de número de diapositiva"/>
-          <p:cNvSpPr>
-            <a:spLocks noGrp="1"/>
-          </p:cNvSpPr>
-          <p:nvPr>
-            <p:ph type="sldNum" sz="quarter" idx="12"/>
-          </p:nvPr>
-        </p:nvSpPr>
-        <p:spPr/>
-        <p:txBody>
-          <a:bodyPr/>
-          <a:lstStyle/>
-          <a:p>
-            <a:fld id="{45F1CE28-A3C7-48DC-84A2-8FB08D6123C5}" type="slidenum">
-              <a:rPr lang="en-US" smtClean="0"/>
-              <a:pPr/>
-              <a:t>8</a:t>
-            </a:fld>
-            <a:endParaRPr lang="en-US" dirty="0"/>
-          </a:p>
-        </p:txBody>
-      </p:sp>
       <p:graphicFrame>
         <p:nvGraphicFramePr>
           <p:cNvPr id="22" name="21 Tabla"/>
@@ -49170,30 +48687,6 @@
               <a:rPr lang="es-CO" sz="2200" dirty="0"/>
               <a:t>Un operador relacional compara sus operandos y devuelve un valor lógico (booleano) basado en si la comparación es verdad o no. </a:t>
             </a:r>
-          </a:p>
-        </p:txBody>
-      </p:sp>
-      <p:sp>
-        <p:nvSpPr>
-          <p:cNvPr id="4" name="3 Marcador de número de diapositiva"/>
-          <p:cNvSpPr>
-            <a:spLocks noGrp="1"/>
-          </p:cNvSpPr>
-          <p:nvPr>
-            <p:ph type="sldNum" sz="quarter" idx="12"/>
-          </p:nvPr>
-        </p:nvSpPr>
-        <p:spPr/>
-        <p:txBody>
-          <a:bodyPr/>
-          <a:lstStyle/>
-          <a:p>
-            <a:fld id="{45F1CE28-A3C7-48DC-84A2-8FB08D6123C5}" type="slidenum">
-              <a:rPr lang="en-US" smtClean="0"/>
-              <a:pPr/>
-              <a:t>9</a:t>
-            </a:fld>
-            <a:endParaRPr lang="en-US" dirty="0"/>
           </a:p>
         </p:txBody>
       </p:sp>

</xml_diff>